<commit_message>
Refactor AI PPT agent workflow with per-slide content generation
</commit_message>
<xml_diff>
--- a/bodytemplates/3 points/1.pptx
+++ b/bodytemplates/3 points/1.pptx
@@ -259,7 +259,7 @@
           <a:p>
             <a:fld id="{9BF13875-5B45-4F9D-9285-E7BA85CFB8AD}" type="datetimeFigureOut">
               <a:rPr lang="en-US" smtClean="0"/>
-              <a:t>7/25/2026</a:t>
+              <a:t>8/1/2026</a:t>
             </a:fld>
             <a:endParaRPr lang="en-US"/>
           </a:p>
@@ -457,7 +457,7 @@
           <a:p>
             <a:fld id="{9BF13875-5B45-4F9D-9285-E7BA85CFB8AD}" type="datetimeFigureOut">
               <a:rPr lang="en-US" smtClean="0"/>
-              <a:t>7/25/2026</a:t>
+              <a:t>8/1/2026</a:t>
             </a:fld>
             <a:endParaRPr lang="en-US"/>
           </a:p>
@@ -665,7 +665,7 @@
           <a:p>
             <a:fld id="{9BF13875-5B45-4F9D-9285-E7BA85CFB8AD}" type="datetimeFigureOut">
               <a:rPr lang="en-US" smtClean="0"/>
-              <a:t>7/25/2026</a:t>
+              <a:t>8/1/2026</a:t>
             </a:fld>
             <a:endParaRPr lang="en-US"/>
           </a:p>
@@ -863,7 +863,7 @@
           <a:p>
             <a:fld id="{9BF13875-5B45-4F9D-9285-E7BA85CFB8AD}" type="datetimeFigureOut">
               <a:rPr lang="en-US" smtClean="0"/>
-              <a:t>7/25/2026</a:t>
+              <a:t>8/1/2026</a:t>
             </a:fld>
             <a:endParaRPr lang="en-US"/>
           </a:p>
@@ -1138,7 +1138,7 @@
           <a:p>
             <a:fld id="{9BF13875-5B45-4F9D-9285-E7BA85CFB8AD}" type="datetimeFigureOut">
               <a:rPr lang="en-US" smtClean="0"/>
-              <a:t>7/25/2026</a:t>
+              <a:t>8/1/2026</a:t>
             </a:fld>
             <a:endParaRPr lang="en-US"/>
           </a:p>
@@ -1403,7 +1403,7 @@
           <a:p>
             <a:fld id="{9BF13875-5B45-4F9D-9285-E7BA85CFB8AD}" type="datetimeFigureOut">
               <a:rPr lang="en-US" smtClean="0"/>
-              <a:t>7/25/2026</a:t>
+              <a:t>8/1/2026</a:t>
             </a:fld>
             <a:endParaRPr lang="en-US"/>
           </a:p>
@@ -1815,7 +1815,7 @@
           <a:p>
             <a:fld id="{9BF13875-5B45-4F9D-9285-E7BA85CFB8AD}" type="datetimeFigureOut">
               <a:rPr lang="en-US" smtClean="0"/>
-              <a:t>7/25/2026</a:t>
+              <a:t>8/1/2026</a:t>
             </a:fld>
             <a:endParaRPr lang="en-US"/>
           </a:p>
@@ -1956,7 +1956,7 @@
           <a:p>
             <a:fld id="{9BF13875-5B45-4F9D-9285-E7BA85CFB8AD}" type="datetimeFigureOut">
               <a:rPr lang="en-US" smtClean="0"/>
-              <a:t>7/25/2026</a:t>
+              <a:t>8/1/2026</a:t>
             </a:fld>
             <a:endParaRPr lang="en-US"/>
           </a:p>
@@ -2069,7 +2069,7 @@
           <a:p>
             <a:fld id="{9BF13875-5B45-4F9D-9285-E7BA85CFB8AD}" type="datetimeFigureOut">
               <a:rPr lang="en-US" smtClean="0"/>
-              <a:t>7/25/2026</a:t>
+              <a:t>8/1/2026</a:t>
             </a:fld>
             <a:endParaRPr lang="en-US"/>
           </a:p>
@@ -2380,7 +2380,7 @@
           <a:p>
             <a:fld id="{9BF13875-5B45-4F9D-9285-E7BA85CFB8AD}" type="datetimeFigureOut">
               <a:rPr lang="en-US" smtClean="0"/>
-              <a:t>7/25/2026</a:t>
+              <a:t>8/1/2026</a:t>
             </a:fld>
             <a:endParaRPr lang="en-US"/>
           </a:p>
@@ -2668,7 +2668,7 @@
           <a:p>
             <a:fld id="{9BF13875-5B45-4F9D-9285-E7BA85CFB8AD}" type="datetimeFigureOut">
               <a:rPr lang="en-US" smtClean="0"/>
-              <a:t>7/25/2026</a:t>
+              <a:t>8/1/2026</a:t>
             </a:fld>
             <a:endParaRPr lang="en-US"/>
           </a:p>
@@ -2909,7 +2909,7 @@
           <a:p>
             <a:fld id="{9BF13875-5B45-4F9D-9285-E7BA85CFB8AD}" type="datetimeFigureOut">
               <a:rPr lang="en-US" smtClean="0"/>
-              <a:t>7/25/2026</a:t>
+              <a:t>8/1/2026</a:t>
             </a:fld>
             <a:endParaRPr lang="en-US"/>
           </a:p>
@@ -3647,8 +3647,8 @@
         </p:nvSpPr>
         <p:spPr>
           <a:xfrm>
-            <a:off x="737805" y="5355452"/>
-            <a:ext cx="4144346" cy="646331"/>
+            <a:off x="318052" y="5355452"/>
+            <a:ext cx="4564099" cy="646331"/>
           </a:xfrm>
           <a:prstGeom prst="rect">
             <a:avLst/>
@@ -3693,8 +3693,8 @@
         </p:nvSpPr>
         <p:spPr>
           <a:xfrm>
-            <a:off x="737805" y="4770677"/>
-            <a:ext cx="4144346" cy="584775"/>
+            <a:off x="318052" y="4770677"/>
+            <a:ext cx="4564099" cy="584775"/>
           </a:xfrm>
           <a:prstGeom prst="rect">
             <a:avLst/>
@@ -3729,8 +3729,8 @@
         </p:nvSpPr>
         <p:spPr>
           <a:xfrm>
-            <a:off x="5968367" y="3751471"/>
-            <a:ext cx="4144346" cy="646331"/>
+            <a:off x="5968366" y="3751471"/>
+            <a:ext cx="5945321" cy="646331"/>
           </a:xfrm>
           <a:prstGeom prst="rect">
             <a:avLst/>
@@ -3775,8 +3775,8 @@
         </p:nvSpPr>
         <p:spPr>
           <a:xfrm>
-            <a:off x="5968367" y="3166696"/>
-            <a:ext cx="4144346" cy="584775"/>
+            <a:off x="5968366" y="3166696"/>
+            <a:ext cx="5945309" cy="584775"/>
           </a:xfrm>
           <a:prstGeom prst="rect">
             <a:avLst/>
@@ -3811,8 +3811,8 @@
         </p:nvSpPr>
         <p:spPr>
           <a:xfrm>
-            <a:off x="737805" y="2098358"/>
-            <a:ext cx="4144346" cy="646331"/>
+            <a:off x="318052" y="2098358"/>
+            <a:ext cx="4564099" cy="646331"/>
           </a:xfrm>
           <a:prstGeom prst="rect">
             <a:avLst/>
@@ -3857,8 +3857,8 @@
         </p:nvSpPr>
         <p:spPr>
           <a:xfrm>
-            <a:off x="737805" y="1513583"/>
-            <a:ext cx="4144346" cy="584775"/>
+            <a:off x="318052" y="1513583"/>
+            <a:ext cx="4564099" cy="584775"/>
           </a:xfrm>
           <a:prstGeom prst="rect">
             <a:avLst/>

</xml_diff>